<commit_message>
docs: improve seating table header spacing
</commit_message>
<xml_diff>
--- a/docs/Phase3_Exam_Seating_Presentation.pptx
+++ b/docs/Phase3_Exam_Seating_Presentation.pptx
@@ -2,22 +2,22 @@
 <file path=ppt/presentation.xml><?xml version="1.0" encoding="utf-8"?>
 <p:presentation xmlns:p="http://schemas.openxmlformats.org/presentationml/2006/main">
   <p:sldMasterIdLst>
-    <p:sldMasterId xmlns:r="http://schemas.openxmlformats.org/officeDocument/2006/relationships" id="2147483648" r:id="Rb4841c7fe9154206"/>
+    <p:sldMasterId xmlns:r="http://schemas.openxmlformats.org/officeDocument/2006/relationships" id="2147483648" r:id="Rda52d5b5fda74b34"/>
   </p:sldMasterIdLst>
   <p:notesMasterIdLst>
-    <p:notesMasterId xmlns:r="http://schemas.openxmlformats.org/officeDocument/2006/relationships" r:id="R6ce446cec2bf42c8"/>
+    <p:notesMasterId xmlns:r="http://schemas.openxmlformats.org/officeDocument/2006/relationships" r:id="Rd199320d0bea4fef"/>
   </p:notesMasterIdLst>
   <p:sldIdLst>
-    <p:sldId xmlns:r="http://schemas.openxmlformats.org/officeDocument/2006/relationships" id="256" r:id="Reaef7aea68a6491d"/>
-    <p:sldId xmlns:r="http://schemas.openxmlformats.org/officeDocument/2006/relationships" id="257" r:id="Rb9ea79d9bc224718"/>
-    <p:sldId xmlns:r="http://schemas.openxmlformats.org/officeDocument/2006/relationships" id="258" r:id="R7c2286b26f9e40d6"/>
-    <p:sldId xmlns:r="http://schemas.openxmlformats.org/officeDocument/2006/relationships" id="259" r:id="R6999a3d38b3348fd"/>
-    <p:sldId xmlns:r="http://schemas.openxmlformats.org/officeDocument/2006/relationships" id="260" r:id="R30f156338b8e4090"/>
-    <p:sldId xmlns:r="http://schemas.openxmlformats.org/officeDocument/2006/relationships" id="261" r:id="R40630e6ae3f84315"/>
-    <p:sldId xmlns:r="http://schemas.openxmlformats.org/officeDocument/2006/relationships" id="262" r:id="Rc331e015b7204fce"/>
-    <p:sldId xmlns:r="http://schemas.openxmlformats.org/officeDocument/2006/relationships" id="263" r:id="R34b890d732fa4316"/>
-    <p:sldId xmlns:r="http://schemas.openxmlformats.org/officeDocument/2006/relationships" id="264" r:id="R0fb8a1f760334d16"/>
-    <p:sldId xmlns:r="http://schemas.openxmlformats.org/officeDocument/2006/relationships" id="265" r:id="Rca82dc1a23b242e7"/>
+    <p:sldId xmlns:r="http://schemas.openxmlformats.org/officeDocument/2006/relationships" id="256" r:id="Raeeab4aca95542ce"/>
+    <p:sldId xmlns:r="http://schemas.openxmlformats.org/officeDocument/2006/relationships" id="257" r:id="R2758fafd6cea4eae"/>
+    <p:sldId xmlns:r="http://schemas.openxmlformats.org/officeDocument/2006/relationships" id="258" r:id="R6a2c9bb492f0451d"/>
+    <p:sldId xmlns:r="http://schemas.openxmlformats.org/officeDocument/2006/relationships" id="259" r:id="Rbe5a90acef2a41b3"/>
+    <p:sldId xmlns:r="http://schemas.openxmlformats.org/officeDocument/2006/relationships" id="260" r:id="Rd24c5c18733c4fd4"/>
+    <p:sldId xmlns:r="http://schemas.openxmlformats.org/officeDocument/2006/relationships" id="261" r:id="R7039e9635ad54003"/>
+    <p:sldId xmlns:r="http://schemas.openxmlformats.org/officeDocument/2006/relationships" id="262" r:id="R35c4dc36e16f49fb"/>
+    <p:sldId xmlns:r="http://schemas.openxmlformats.org/officeDocument/2006/relationships" id="263" r:id="R3bb9d0df962a4337"/>
+    <p:sldId xmlns:r="http://schemas.openxmlformats.org/officeDocument/2006/relationships" id="264" r:id="Re13145c61f794e96"/>
+    <p:sldId xmlns:r="http://schemas.openxmlformats.org/officeDocument/2006/relationships" id="265" r:id="Rc1d88b88fbbb403e"/>
   </p:sldIdLst>
   <p:sldSz cx="12192000" cy="6858000"/>
   <p:notesSz cx="6858000" cy="9144000"/>
@@ -1128,7 +1128,7 @@
           <p:cNvPr id="3" name="Title">
             <a:extLst xmlns:a="http://schemas.openxmlformats.org/drawingml/2006/main">
               <a:ext uri="{FF2B5EF4-FFF2-40B4-BE49-F238E27FC236}">
-                <a16:creationId xmlns:a16="http://schemas.microsoft.com/office/drawing/2014/main" id="{1774A5A8-C4C8-48A4-921C-3C0EC894B28B}"/>
+                <a16:creationId xmlns:a16="http://schemas.microsoft.com/office/drawing/2014/main" id="{5F5B197F-1492-4C27-BC8C-EB087819E3CA}"/>
               </a:ext>
             </a:extLst>
           </p:cNvPr>
@@ -1285,7 +1285,7 @@
           <p:cNvPr id="2" name="Subtitle">
             <a:extLst xmlns:a="http://schemas.openxmlformats.org/drawingml/2006/main">
               <a:ext uri="{FF2B5EF4-FFF2-40B4-BE49-F238E27FC236}">
-                <a16:creationId xmlns:a16="http://schemas.microsoft.com/office/drawing/2014/main" id="{E60D0506-46E3-4E56-A04E-79E31EE9FADA}"/>
+                <a16:creationId xmlns:a16="http://schemas.microsoft.com/office/drawing/2014/main" id="{93482B8A-E3F8-4AD6-B179-E89F3E3DFE57}"/>
               </a:ext>
             </a:extLst>
           </p:cNvPr>
@@ -1459,7 +1459,7 @@
           <p:cNvPr id="2" name="Section title">
             <a:extLst xmlns:a="http://schemas.openxmlformats.org/drawingml/2006/main">
               <a:ext uri="{FF2B5EF4-FFF2-40B4-BE49-F238E27FC236}">
-                <a16:creationId xmlns:a16="http://schemas.microsoft.com/office/drawing/2014/main" id="{026AA36C-8B5C-4528-A485-99952DDD16A5}"/>
+                <a16:creationId xmlns:a16="http://schemas.microsoft.com/office/drawing/2014/main" id="{2C1F0058-FA46-4C36-9298-D13003F06CA7}"/>
               </a:ext>
             </a:extLst>
           </p:cNvPr>
@@ -1633,7 +1633,7 @@
           <p:cNvPr id="3" name="Title">
             <a:extLst xmlns:a="http://schemas.openxmlformats.org/drawingml/2006/main">
               <a:ext uri="{FF2B5EF4-FFF2-40B4-BE49-F238E27FC236}">
-                <a16:creationId xmlns:a16="http://schemas.microsoft.com/office/drawing/2014/main" id="{85C98834-6586-4883-A357-1DC0B4C6363C}"/>
+                <a16:creationId xmlns:a16="http://schemas.microsoft.com/office/drawing/2014/main" id="{1EF1F5B0-12D0-4E55-8147-650A63805260}"/>
               </a:ext>
             </a:extLst>
           </p:cNvPr>
@@ -1790,7 +1790,7 @@
           <p:cNvPr id="2" name="Body">
             <a:extLst xmlns:a="http://schemas.openxmlformats.org/drawingml/2006/main">
               <a:ext uri="{FF2B5EF4-FFF2-40B4-BE49-F238E27FC236}">
-                <a16:creationId xmlns:a16="http://schemas.microsoft.com/office/drawing/2014/main" id="{1F9F17EC-CDD0-41ED-823E-31F888E0C4CD}"/>
+                <a16:creationId xmlns:a16="http://schemas.microsoft.com/office/drawing/2014/main" id="{2444511A-2AC6-4EFB-8935-8EC4CE1FCBEC}"/>
               </a:ext>
             </a:extLst>
           </p:cNvPr>
@@ -1964,7 +1964,7 @@
           <p:cNvPr id="4" name="Title">
             <a:extLst xmlns:a="http://schemas.openxmlformats.org/drawingml/2006/main">
               <a:ext uri="{FF2B5EF4-FFF2-40B4-BE49-F238E27FC236}">
-                <a16:creationId xmlns:a16="http://schemas.microsoft.com/office/drawing/2014/main" id="{1F7DE90B-A8BD-49CA-83A9-B5FBE0A1B597}"/>
+                <a16:creationId xmlns:a16="http://schemas.microsoft.com/office/drawing/2014/main" id="{9EC9CC24-6083-4FDC-AA84-2FBC17888AF1}"/>
               </a:ext>
             </a:extLst>
           </p:cNvPr>
@@ -2121,7 +2121,7 @@
           <p:cNvPr id="2" name="Left column">
             <a:extLst xmlns:a="http://schemas.openxmlformats.org/drawingml/2006/main">
               <a:ext uri="{FF2B5EF4-FFF2-40B4-BE49-F238E27FC236}">
-                <a16:creationId xmlns:a16="http://schemas.microsoft.com/office/drawing/2014/main" id="{090E88B8-73D4-43DF-B3E4-F82133E34231}"/>
+                <a16:creationId xmlns:a16="http://schemas.microsoft.com/office/drawing/2014/main" id="{F4A74C34-F3F7-4B16-8269-55E311991C00}"/>
               </a:ext>
             </a:extLst>
           </p:cNvPr>
@@ -2278,7 +2278,7 @@
           <p:cNvPr id="3" name="Right column">
             <a:extLst xmlns:a="http://schemas.openxmlformats.org/drawingml/2006/main">
               <a:ext uri="{FF2B5EF4-FFF2-40B4-BE49-F238E27FC236}">
-                <a16:creationId xmlns:a16="http://schemas.microsoft.com/office/drawing/2014/main" id="{BD5C98E5-917A-46D7-8973-7DB9DA9469C5}"/>
+                <a16:creationId xmlns:a16="http://schemas.microsoft.com/office/drawing/2014/main" id="{A3AC7EF2-682D-4CC7-B19E-D97D09F9A387}"/>
               </a:ext>
             </a:extLst>
           </p:cNvPr>
@@ -2452,7 +2452,7 @@
           <p:cNvPr id="3" name="Title">
             <a:extLst xmlns:a="http://schemas.openxmlformats.org/drawingml/2006/main">
               <a:ext uri="{FF2B5EF4-FFF2-40B4-BE49-F238E27FC236}">
-                <a16:creationId xmlns:a16="http://schemas.microsoft.com/office/drawing/2014/main" id="{DF014B57-6A6F-4591-BAB7-2D1C60D00B4F}"/>
+                <a16:creationId xmlns:a16="http://schemas.microsoft.com/office/drawing/2014/main" id="{B477DE39-1C41-479F-9607-3FD4724AA1BF}"/>
               </a:ext>
             </a:extLst>
           </p:cNvPr>
@@ -2609,7 +2609,7 @@
           <p:cNvPr id="2" name="Left column">
             <a:extLst xmlns:a="http://schemas.openxmlformats.org/drawingml/2006/main">
               <a:ext uri="{FF2B5EF4-FFF2-40B4-BE49-F238E27FC236}">
-                <a16:creationId xmlns:a16="http://schemas.microsoft.com/office/drawing/2014/main" id="{996336F5-2782-4CC1-ABC3-67EE1FF5CA89}"/>
+                <a16:creationId xmlns:a16="http://schemas.microsoft.com/office/drawing/2014/main" id="{97A30EFC-D72C-4F83-99B5-CE3D2BACC7B1}"/>
               </a:ext>
             </a:extLst>
           </p:cNvPr>
@@ -2804,12 +2804,12 @@
   </p:cSld>
   <p:clrMap bg1="lt1" tx1="dk1" bg2="lt2" tx2="dk2" accent1="accent1" accent2="accent2" accent3="accent3" accent4="accent4" accent5="accent5" accent6="accent6" hlink="hlink" folHlink="folHlink"/>
   <p:sldLayoutIdLst>
-    <p:sldLayoutId xmlns:r="http://schemas.openxmlformats.org/officeDocument/2006/relationships" id="2147483649" r:id="Rc20abd21b4914bbd"/>
-    <p:sldLayoutId xmlns:r="http://schemas.openxmlformats.org/officeDocument/2006/relationships" id="2147483650" r:id="Re304a25bf00b4cd4"/>
-    <p:sldLayoutId xmlns:r="http://schemas.openxmlformats.org/officeDocument/2006/relationships" id="2147483651" r:id="R1aa74aaa4c004562"/>
-    <p:sldLayoutId xmlns:r="http://schemas.openxmlformats.org/officeDocument/2006/relationships" id="2147483652" r:id="R1fef50f1213c4505"/>
-    <p:sldLayoutId xmlns:r="http://schemas.openxmlformats.org/officeDocument/2006/relationships" id="2147483653" r:id="Rb10a05b0a7ae452a"/>
-    <p:sldLayoutId xmlns:r="http://schemas.openxmlformats.org/officeDocument/2006/relationships" id="2147483654" r:id="Rf0ee61be50f24fb5"/>
+    <p:sldLayoutId xmlns:r="http://schemas.openxmlformats.org/officeDocument/2006/relationships" id="2147483649" r:id="R75a1291c5e3b4d4a"/>
+    <p:sldLayoutId xmlns:r="http://schemas.openxmlformats.org/officeDocument/2006/relationships" id="2147483650" r:id="R1486732dec1549e2"/>
+    <p:sldLayoutId xmlns:r="http://schemas.openxmlformats.org/officeDocument/2006/relationships" id="2147483651" r:id="Rd6ce3cd7e7d14874"/>
+    <p:sldLayoutId xmlns:r="http://schemas.openxmlformats.org/officeDocument/2006/relationships" id="2147483652" r:id="R49b780137f464363"/>
+    <p:sldLayoutId xmlns:r="http://schemas.openxmlformats.org/officeDocument/2006/relationships" id="2147483653" r:id="R3fbf658fc69f480b"/>
+    <p:sldLayoutId xmlns:r="http://schemas.openxmlformats.org/officeDocument/2006/relationships" id="2147483654" r:id="R478b490655fa4552"/>
   </p:sldLayoutIdLst>
   <p:txStyles>
     <p:titleStyle>
@@ -3360,7 +3360,7 @@
           <p:cNvPr id="7" name="">
             <a:extLst xmlns:a="http://schemas.openxmlformats.org/drawingml/2006/main">
               <a:ext uri="{FF2B5EF4-FFF2-40B4-BE49-F238E27FC236}">
-                <a16:creationId xmlns:a16="http://schemas.microsoft.com/office/drawing/2014/main" id="{C2ECA01E-DEF4-4841-9775-B1DB1B3D0E7D}"/>
+                <a16:creationId xmlns:a16="http://schemas.microsoft.com/office/drawing/2014/main" id="{1C3AF9B3-BE56-416D-B30D-9B4018004E67}"/>
               </a:ext>
             </a:extLst>
           </p:cNvPr>
@@ -3449,7 +3449,7 @@
           <p:cNvPr id="2" name="">
             <a:extLst xmlns:a="http://schemas.openxmlformats.org/drawingml/2006/main">
               <a:ext uri="{FF2B5EF4-FFF2-40B4-BE49-F238E27FC236}">
-                <a16:creationId xmlns:a16="http://schemas.microsoft.com/office/drawing/2014/main" id="{7F6B00AD-163D-4C32-B4C7-7A7283BD90E9}"/>
+                <a16:creationId xmlns:a16="http://schemas.microsoft.com/office/drawing/2014/main" id="{9B467027-E5B1-4930-BF11-C6CBFF92A326}"/>
               </a:ext>
             </a:extLst>
           </p:cNvPr>
@@ -3515,7 +3515,7 @@
           <p:cNvPr id="3" name="">
             <a:extLst xmlns:a="http://schemas.openxmlformats.org/drawingml/2006/main">
               <a:ext uri="{FF2B5EF4-FFF2-40B4-BE49-F238E27FC236}">
-                <a16:creationId xmlns:a16="http://schemas.microsoft.com/office/drawing/2014/main" id="{82F14EEF-E849-42D5-BECE-9D61EFA988D5}"/>
+                <a16:creationId xmlns:a16="http://schemas.microsoft.com/office/drawing/2014/main" id="{43DB13CF-5555-40FD-9196-2631ACD9B82D}"/>
               </a:ext>
             </a:extLst>
           </p:cNvPr>
@@ -3581,7 +3581,7 @@
           <p:cNvPr id="4" name="">
             <a:extLst xmlns:a="http://schemas.openxmlformats.org/drawingml/2006/main">
               <a:ext uri="{FF2B5EF4-FFF2-40B4-BE49-F238E27FC236}">
-                <a16:creationId xmlns:a16="http://schemas.microsoft.com/office/drawing/2014/main" id="{99105503-1FC0-4B0E-9875-38ACB1DD6D8B}"/>
+                <a16:creationId xmlns:a16="http://schemas.microsoft.com/office/drawing/2014/main" id="{F295EC4E-D4B3-40AE-8228-8057A7AD725F}"/>
               </a:ext>
             </a:extLst>
           </p:cNvPr>
@@ -3670,7 +3670,7 @@
           <p:cNvPr id="5" name="">
             <a:extLst xmlns:a="http://schemas.openxmlformats.org/drawingml/2006/main">
               <a:ext uri="{FF2B5EF4-FFF2-40B4-BE49-F238E27FC236}">
-                <a16:creationId xmlns:a16="http://schemas.microsoft.com/office/drawing/2014/main" id="{B4191340-3F9A-4F5D-B09B-D62ED30DCA97}"/>
+                <a16:creationId xmlns:a16="http://schemas.microsoft.com/office/drawing/2014/main" id="{9AC48BB4-8486-452B-A492-A1F4E357721E}"/>
               </a:ext>
             </a:extLst>
           </p:cNvPr>
@@ -3782,7 +3782,7 @@
           <p:cNvPr id="6" name="">
             <a:extLst xmlns:a="http://schemas.openxmlformats.org/drawingml/2006/main">
               <a:ext uri="{FF2B5EF4-FFF2-40B4-BE49-F238E27FC236}">
-                <a16:creationId xmlns:a16="http://schemas.microsoft.com/office/drawing/2014/main" id="{87DBD795-1448-4FBE-BA81-32EDBDB24549}"/>
+                <a16:creationId xmlns:a16="http://schemas.microsoft.com/office/drawing/2014/main" id="{CA37973D-69B7-4D4B-BD20-6B121B368005}"/>
               </a:ext>
             </a:extLst>
           </p:cNvPr>
@@ -3869,7 +3869,7 @@
     </p:spTree>
     <p:extLst>
       <p:ext uri="{BB962C8B-B14F-4D97-AF65-F5344CB8AC3E}">
-        <p14:creationId xmlns:p14="http://schemas.microsoft.com/office/powerpoint/2010/main" val="1844237082"/>
+        <p14:creationId xmlns:p14="http://schemas.microsoft.com/office/powerpoint/2010/main" val="808471455"/>
       </p:ext>
     </p:extLst>
   </p:cSld>
@@ -3900,7 +3900,7 @@
           <p:cNvPr id="5" name="">
             <a:extLst xmlns:a="http://schemas.openxmlformats.org/drawingml/2006/main">
               <a:ext uri="{FF2B5EF4-FFF2-40B4-BE49-F238E27FC236}">
-                <a16:creationId xmlns:a16="http://schemas.microsoft.com/office/drawing/2014/main" id="{1349795F-241C-4F3E-9F09-4C3E738C573F}"/>
+                <a16:creationId xmlns:a16="http://schemas.microsoft.com/office/drawing/2014/main" id="{EAAB8521-92DB-4022-A40C-C24E14E7A0A0}"/>
               </a:ext>
             </a:extLst>
           </p:cNvPr>
@@ -3966,7 +3966,7 @@
           <p:cNvPr id="2" name="">
             <a:extLst xmlns:a="http://schemas.openxmlformats.org/drawingml/2006/main">
               <a:ext uri="{FF2B5EF4-FFF2-40B4-BE49-F238E27FC236}">
-                <a16:creationId xmlns:a16="http://schemas.microsoft.com/office/drawing/2014/main" id="{083C053B-A5E6-4B28-B1C0-80964A807E89}"/>
+                <a16:creationId xmlns:a16="http://schemas.microsoft.com/office/drawing/2014/main" id="{DEF58B2C-0D4A-4AE9-AE5C-A808E6AE6D9F}"/>
               </a:ext>
             </a:extLst>
           </p:cNvPr>
@@ -4032,7 +4032,7 @@
           <p:cNvPr id="3" name="">
             <a:extLst xmlns:a="http://schemas.openxmlformats.org/drawingml/2006/main">
               <a:ext uri="{FF2B5EF4-FFF2-40B4-BE49-F238E27FC236}">
-                <a16:creationId xmlns:a16="http://schemas.microsoft.com/office/drawing/2014/main" id="{F16BB2E3-5BF5-4959-9C96-D4144170356D}"/>
+                <a16:creationId xmlns:a16="http://schemas.microsoft.com/office/drawing/2014/main" id="{EA2396F5-7707-4488-B903-1FD79867A058}"/>
               </a:ext>
             </a:extLst>
           </p:cNvPr>
@@ -4310,7 +4310,7 @@
           <p:cNvPr id="4" name="">
             <a:extLst xmlns:a="http://schemas.openxmlformats.org/drawingml/2006/main">
               <a:ext uri="{FF2B5EF4-FFF2-40B4-BE49-F238E27FC236}">
-                <a16:creationId xmlns:a16="http://schemas.microsoft.com/office/drawing/2014/main" id="{863E6556-E699-4699-88BA-AD457772F1FA}"/>
+                <a16:creationId xmlns:a16="http://schemas.microsoft.com/office/drawing/2014/main" id="{376E7BB5-E872-4573-9EC9-87A92963F1D6}"/>
               </a:ext>
             </a:extLst>
           </p:cNvPr>
@@ -4397,7 +4397,7 @@
     </p:spTree>
     <p:extLst>
       <p:ext uri="{BB962C8B-B14F-4D97-AF65-F5344CB8AC3E}">
-        <p14:creationId xmlns:p14="http://schemas.microsoft.com/office/powerpoint/2010/main" val="902842870"/>
+        <p14:creationId xmlns:p14="http://schemas.microsoft.com/office/powerpoint/2010/main" val="936531873"/>
       </p:ext>
     </p:extLst>
   </p:cSld>
@@ -4428,7 +4428,7 @@
           <p:cNvPr id="5" name="">
             <a:extLst xmlns:a="http://schemas.openxmlformats.org/drawingml/2006/main">
               <a:ext uri="{FF2B5EF4-FFF2-40B4-BE49-F238E27FC236}">
-                <a16:creationId xmlns:a16="http://schemas.microsoft.com/office/drawing/2014/main" id="{1573E555-F840-4261-A9BD-E90A96401B0B}"/>
+                <a16:creationId xmlns:a16="http://schemas.microsoft.com/office/drawing/2014/main" id="{F5A7D761-D85D-4A84-A46D-9CC629DF0F37}"/>
               </a:ext>
             </a:extLst>
           </p:cNvPr>
@@ -4494,7 +4494,7 @@
           <p:cNvPr id="2" name="">
             <a:extLst xmlns:a="http://schemas.openxmlformats.org/drawingml/2006/main">
               <a:ext uri="{FF2B5EF4-FFF2-40B4-BE49-F238E27FC236}">
-                <a16:creationId xmlns:a16="http://schemas.microsoft.com/office/drawing/2014/main" id="{AE1E33D3-B5C0-4B0A-99B8-A1E732728D48}"/>
+                <a16:creationId xmlns:a16="http://schemas.microsoft.com/office/drawing/2014/main" id="{FFAF1D36-EA23-45FE-85D4-243A5C43E33E}"/>
               </a:ext>
             </a:extLst>
           </p:cNvPr>
@@ -4560,7 +4560,7 @@
           <p:cNvPr id="3" name="">
             <a:extLst xmlns:a="http://schemas.openxmlformats.org/drawingml/2006/main">
               <a:ext uri="{FF2B5EF4-FFF2-40B4-BE49-F238E27FC236}">
-                <a16:creationId xmlns:a16="http://schemas.microsoft.com/office/drawing/2014/main" id="{05697368-91C6-46FD-9E87-BE46EB09775E}"/>
+                <a16:creationId xmlns:a16="http://schemas.microsoft.com/office/drawing/2014/main" id="{1D381542-B960-4111-8666-A64CF340EB7C}"/>
               </a:ext>
             </a:extLst>
           </p:cNvPr>
@@ -4959,7 +4959,7 @@
           <p:cNvPr id="4" name="">
             <a:extLst xmlns:a="http://schemas.openxmlformats.org/drawingml/2006/main">
               <a:ext uri="{FF2B5EF4-FFF2-40B4-BE49-F238E27FC236}">
-                <a16:creationId xmlns:a16="http://schemas.microsoft.com/office/drawing/2014/main" id="{BC52E17C-AA00-4EC1-908D-F8EF24FDE65F}"/>
+                <a16:creationId xmlns:a16="http://schemas.microsoft.com/office/drawing/2014/main" id="{0A0FC3A7-8E97-4A70-82BC-C72BF344A9C0}"/>
               </a:ext>
             </a:extLst>
           </p:cNvPr>
@@ -5023,7 +5023,7 @@
     </p:spTree>
     <p:extLst>
       <p:ext uri="{BB962C8B-B14F-4D97-AF65-F5344CB8AC3E}">
-        <p14:creationId xmlns:p14="http://schemas.microsoft.com/office/powerpoint/2010/main" val="385644517"/>
+        <p14:creationId xmlns:p14="http://schemas.microsoft.com/office/powerpoint/2010/main" val="1673239716"/>
       </p:ext>
     </p:extLst>
   </p:cSld>
@@ -5054,7 +5054,7 @@
           <p:cNvPr id="4" name="">
             <a:extLst xmlns:a="http://schemas.openxmlformats.org/drawingml/2006/main">
               <a:ext uri="{FF2B5EF4-FFF2-40B4-BE49-F238E27FC236}">
-                <a16:creationId xmlns:a16="http://schemas.microsoft.com/office/drawing/2014/main" id="{6D6A5C31-BB8B-431D-A0D7-75E07E43B26E}"/>
+                <a16:creationId xmlns:a16="http://schemas.microsoft.com/office/drawing/2014/main" id="{3525EC94-AE43-48C4-9E2D-BF16ED13F4DD}"/>
               </a:ext>
             </a:extLst>
           </p:cNvPr>
@@ -5120,7 +5120,7 @@
           <p:cNvPr id="2" name="">
             <a:extLst xmlns:a="http://schemas.openxmlformats.org/drawingml/2006/main">
               <a:ext uri="{FF2B5EF4-FFF2-40B4-BE49-F238E27FC236}">
-                <a16:creationId xmlns:a16="http://schemas.microsoft.com/office/drawing/2014/main" id="{C0E2D2F6-06F8-401A-83DA-0069A6D6C6F0}"/>
+                <a16:creationId xmlns:a16="http://schemas.microsoft.com/office/drawing/2014/main" id="{B33D2C68-8BA0-4473-B47E-29930168ABE9}"/>
               </a:ext>
             </a:extLst>
           </p:cNvPr>
@@ -5186,7 +5186,7 @@
           <p:cNvPr id="3" name="">
             <a:extLst xmlns:a="http://schemas.openxmlformats.org/drawingml/2006/main">
               <a:ext uri="{FF2B5EF4-FFF2-40B4-BE49-F238E27FC236}">
-                <a16:creationId xmlns:a16="http://schemas.microsoft.com/office/drawing/2014/main" id="{5A6377DB-3029-4FE6-B249-1F370A7236A3}"/>
+                <a16:creationId xmlns:a16="http://schemas.microsoft.com/office/drawing/2014/main" id="{5ECEDAEF-A3BA-44FD-8028-23C815F343F4}"/>
               </a:ext>
             </a:extLst>
           </p:cNvPr>
@@ -5657,7 +5657,7 @@
     </p:spTree>
     <p:extLst>
       <p:ext uri="{BB962C8B-B14F-4D97-AF65-F5344CB8AC3E}">
-        <p14:creationId xmlns:p14="http://schemas.microsoft.com/office/powerpoint/2010/main" val="2040665092"/>
+        <p14:creationId xmlns:p14="http://schemas.microsoft.com/office/powerpoint/2010/main" val="942703575"/>
       </p:ext>
     </p:extLst>
   </p:cSld>
@@ -5688,7 +5688,7 @@
           <p:cNvPr id="5" name="">
             <a:extLst xmlns:a="http://schemas.openxmlformats.org/drawingml/2006/main">
               <a:ext uri="{FF2B5EF4-FFF2-40B4-BE49-F238E27FC236}">
-                <a16:creationId xmlns:a16="http://schemas.microsoft.com/office/drawing/2014/main" id="{7A7757C1-7F03-4167-8E9B-46864E78C224}"/>
+                <a16:creationId xmlns:a16="http://schemas.microsoft.com/office/drawing/2014/main" id="{75889142-030A-456C-984F-D01315A9AF88}"/>
               </a:ext>
             </a:extLst>
           </p:cNvPr>
@@ -5754,7 +5754,7 @@
           <p:cNvPr id="2" name="">
             <a:extLst xmlns:a="http://schemas.openxmlformats.org/drawingml/2006/main">
               <a:ext uri="{FF2B5EF4-FFF2-40B4-BE49-F238E27FC236}">
-                <a16:creationId xmlns:a16="http://schemas.microsoft.com/office/drawing/2014/main" id="{4323EACA-A16F-4CAD-AE41-19C8B40BCE66}"/>
+                <a16:creationId xmlns:a16="http://schemas.microsoft.com/office/drawing/2014/main" id="{FA485CE1-5567-491B-96AF-8D3DCD5CB3E6}"/>
               </a:ext>
             </a:extLst>
           </p:cNvPr>
@@ -5820,7 +5820,7 @@
           <p:cNvPr id="3" name="">
             <a:extLst xmlns:a="http://schemas.openxmlformats.org/drawingml/2006/main">
               <a:ext uri="{FF2B5EF4-FFF2-40B4-BE49-F238E27FC236}">
-                <a16:creationId xmlns:a16="http://schemas.microsoft.com/office/drawing/2014/main" id="{6C8BBF89-8E1A-446C-9E9E-E7C98E846B07}"/>
+                <a16:creationId xmlns:a16="http://schemas.microsoft.com/office/drawing/2014/main" id="{1CC70429-150A-4F7E-BA5C-11DF7C73A244}"/>
               </a:ext>
             </a:extLst>
           </p:cNvPr>
@@ -6219,7 +6219,7 @@
           <p:cNvPr id="4" name="">
             <a:extLst xmlns:a="http://schemas.openxmlformats.org/drawingml/2006/main">
               <a:ext uri="{FF2B5EF4-FFF2-40B4-BE49-F238E27FC236}">
-                <a16:creationId xmlns:a16="http://schemas.microsoft.com/office/drawing/2014/main" id="{5DE2C2C4-353E-4636-B6B0-4003673E05AC}"/>
+                <a16:creationId xmlns:a16="http://schemas.microsoft.com/office/drawing/2014/main" id="{CCCEA812-CB69-45F8-A876-873CFDFC4732}"/>
               </a:ext>
             </a:extLst>
           </p:cNvPr>
@@ -6283,7 +6283,7 @@
     </p:spTree>
     <p:extLst>
       <p:ext uri="{BB962C8B-B14F-4D97-AF65-F5344CB8AC3E}">
-        <p14:creationId xmlns:p14="http://schemas.microsoft.com/office/powerpoint/2010/main" val="751164806"/>
+        <p14:creationId xmlns:p14="http://schemas.microsoft.com/office/powerpoint/2010/main" val="766857452"/>
       </p:ext>
     </p:extLst>
   </p:cSld>
@@ -6314,7 +6314,7 @@
           <p:cNvPr id="16" name="">
             <a:extLst xmlns:a="http://schemas.openxmlformats.org/drawingml/2006/main">
               <a:ext uri="{FF2B5EF4-FFF2-40B4-BE49-F238E27FC236}">
-                <a16:creationId xmlns:a16="http://schemas.microsoft.com/office/drawing/2014/main" id="{5F6150BF-4CE9-4780-A512-7A6E4F4920AE}"/>
+                <a16:creationId xmlns:a16="http://schemas.microsoft.com/office/drawing/2014/main" id="{9B94E696-9622-4CBB-822E-ECCD74436791}"/>
               </a:ext>
             </a:extLst>
           </p:cNvPr>
@@ -6380,7 +6380,7 @@
           <p:cNvPr id="2" name="">
             <a:extLst xmlns:a="http://schemas.openxmlformats.org/drawingml/2006/main">
               <a:ext uri="{FF2B5EF4-FFF2-40B4-BE49-F238E27FC236}">
-                <a16:creationId xmlns:a16="http://schemas.microsoft.com/office/drawing/2014/main" id="{1BDE19DD-9D0C-4197-9A3F-269C5D31D6D3}"/>
+                <a16:creationId xmlns:a16="http://schemas.microsoft.com/office/drawing/2014/main" id="{9E1C5E9E-75CC-4889-90B4-54944540006F}"/>
               </a:ext>
             </a:extLst>
           </p:cNvPr>
@@ -6446,7 +6446,7 @@
           <p:cNvPr id="3" name="">
             <a:extLst xmlns:a="http://schemas.openxmlformats.org/drawingml/2006/main">
               <a:ext uri="{FF2B5EF4-FFF2-40B4-BE49-F238E27FC236}">
-                <a16:creationId xmlns:a16="http://schemas.microsoft.com/office/drawing/2014/main" id="{9DB6A7AF-EE86-4B75-B3D5-30C3BA38381F}"/>
+                <a16:creationId xmlns:a16="http://schemas.microsoft.com/office/drawing/2014/main" id="{E51A2516-52E4-4AEA-8FB2-BA0C9058DEA4}"/>
               </a:ext>
             </a:extLst>
           </p:cNvPr>
@@ -6512,7 +6512,7 @@
           <p:cNvPr id="4" name="">
             <a:extLst xmlns:a="http://schemas.openxmlformats.org/drawingml/2006/main">
               <a:ext uri="{FF2B5EF4-FFF2-40B4-BE49-F238E27FC236}">
-                <a16:creationId xmlns:a16="http://schemas.microsoft.com/office/drawing/2014/main" id="{CE4A8FD0-BDC8-4877-B2CE-E213A0A0D7E2}"/>
+                <a16:creationId xmlns:a16="http://schemas.microsoft.com/office/drawing/2014/main" id="{5387E217-221E-4D90-87CA-866921D715D7}"/>
               </a:ext>
             </a:extLst>
           </p:cNvPr>
@@ -6578,7 +6578,7 @@
           <p:cNvPr id="5" name="">
             <a:extLst xmlns:a="http://schemas.openxmlformats.org/drawingml/2006/main">
               <a:ext uri="{FF2B5EF4-FFF2-40B4-BE49-F238E27FC236}">
-                <a16:creationId xmlns:a16="http://schemas.microsoft.com/office/drawing/2014/main" id="{760BAC1D-FCE4-46B6-B58C-6EFE60132DB0}"/>
+                <a16:creationId xmlns:a16="http://schemas.microsoft.com/office/drawing/2014/main" id="{775E839B-413D-4D7A-A5DA-83A188ECB533}"/>
               </a:ext>
             </a:extLst>
           </p:cNvPr>
@@ -6644,7 +6644,7 @@
           <p:cNvPr id="6" name="">
             <a:extLst xmlns:a="http://schemas.openxmlformats.org/drawingml/2006/main">
               <a:ext uri="{FF2B5EF4-FFF2-40B4-BE49-F238E27FC236}">
-                <a16:creationId xmlns:a16="http://schemas.microsoft.com/office/drawing/2014/main" id="{163B0C52-2C0F-43FE-A776-46107A890152}"/>
+                <a16:creationId xmlns:a16="http://schemas.microsoft.com/office/drawing/2014/main" id="{FCD0E15F-366C-4200-AFF0-86185C8244D5}"/>
               </a:ext>
             </a:extLst>
           </p:cNvPr>
@@ -6710,7 +6710,7 @@
           <p:cNvPr id="7" name="">
             <a:extLst xmlns:a="http://schemas.openxmlformats.org/drawingml/2006/main">
               <a:ext uri="{FF2B5EF4-FFF2-40B4-BE49-F238E27FC236}">
-                <a16:creationId xmlns:a16="http://schemas.microsoft.com/office/drawing/2014/main" id="{23AE517E-051D-4191-81AD-445F6DA341A8}"/>
+                <a16:creationId xmlns:a16="http://schemas.microsoft.com/office/drawing/2014/main" id="{716DC436-C3A0-4CC3-ABFB-11FB63CCA012}"/>
               </a:ext>
             </a:extLst>
           </p:cNvPr>
@@ -6776,7 +6776,7 @@
           <p:cNvPr id="8" name="">
             <a:extLst xmlns:a="http://schemas.openxmlformats.org/drawingml/2006/main">
               <a:ext uri="{FF2B5EF4-FFF2-40B4-BE49-F238E27FC236}">
-                <a16:creationId xmlns:a16="http://schemas.microsoft.com/office/drawing/2014/main" id="{8399EBDC-6C80-473C-A9F0-EBF8759B8FDD}"/>
+                <a16:creationId xmlns:a16="http://schemas.microsoft.com/office/drawing/2014/main" id="{681BD7A6-E694-4458-A281-0EAC0B1B3E8A}"/>
               </a:ext>
             </a:extLst>
           </p:cNvPr>
@@ -6842,7 +6842,7 @@
           <p:cNvPr id="9" name="">
             <a:extLst xmlns:a="http://schemas.openxmlformats.org/drawingml/2006/main">
               <a:ext uri="{FF2B5EF4-FFF2-40B4-BE49-F238E27FC236}">
-                <a16:creationId xmlns:a16="http://schemas.microsoft.com/office/drawing/2014/main" id="{166C1009-C9DA-475C-830E-0593FD268E21}"/>
+                <a16:creationId xmlns:a16="http://schemas.microsoft.com/office/drawing/2014/main" id="{D7A2BDDE-6D27-44B7-9600-EA18C4F34868}"/>
               </a:ext>
             </a:extLst>
           </p:cNvPr>
@@ -6908,7 +6908,7 @@
           <p:cNvPr id="10" name="">
             <a:extLst xmlns:a="http://schemas.openxmlformats.org/drawingml/2006/main">
               <a:ext uri="{FF2B5EF4-FFF2-40B4-BE49-F238E27FC236}">
-                <a16:creationId xmlns:a16="http://schemas.microsoft.com/office/drawing/2014/main" id="{BDCCE3FB-2380-4825-A3B6-04013E01859F}"/>
+                <a16:creationId xmlns:a16="http://schemas.microsoft.com/office/drawing/2014/main" id="{7479F306-1754-4D3F-A504-7EF64ECD9526}"/>
               </a:ext>
             </a:extLst>
           </p:cNvPr>
@@ -6974,7 +6974,7 @@
           <p:cNvPr id="11" name="">
             <a:extLst xmlns:a="http://schemas.openxmlformats.org/drawingml/2006/main">
               <a:ext uri="{FF2B5EF4-FFF2-40B4-BE49-F238E27FC236}">
-                <a16:creationId xmlns:a16="http://schemas.microsoft.com/office/drawing/2014/main" id="{94177038-3341-43AA-922D-3547182B9F10}"/>
+                <a16:creationId xmlns:a16="http://schemas.microsoft.com/office/drawing/2014/main" id="{E1C70C6B-BB71-4C5A-BB92-0FFAFBFA81FB}"/>
               </a:ext>
             </a:extLst>
           </p:cNvPr>
@@ -7040,7 +7040,7 @@
           <p:cNvPr id="12" name="">
             <a:extLst xmlns:a="http://schemas.openxmlformats.org/drawingml/2006/main">
               <a:ext uri="{FF2B5EF4-FFF2-40B4-BE49-F238E27FC236}">
-                <a16:creationId xmlns:a16="http://schemas.microsoft.com/office/drawing/2014/main" id="{82853953-B9A9-4613-B70B-95B9D7200FD9}"/>
+                <a16:creationId xmlns:a16="http://schemas.microsoft.com/office/drawing/2014/main" id="{7556140E-C25A-4115-AF60-8F6B456DECB3}"/>
               </a:ext>
             </a:extLst>
           </p:cNvPr>
@@ -7106,7 +7106,7 @@
           <p:cNvPr id="13" name="">
             <a:extLst xmlns:a="http://schemas.openxmlformats.org/drawingml/2006/main">
               <a:ext uri="{FF2B5EF4-FFF2-40B4-BE49-F238E27FC236}">
-                <a16:creationId xmlns:a16="http://schemas.microsoft.com/office/drawing/2014/main" id="{AB977D41-E0DF-4ED2-A351-07F1E144C5CB}"/>
+                <a16:creationId xmlns:a16="http://schemas.microsoft.com/office/drawing/2014/main" id="{16D8118C-445B-469A-A6D8-22E2B44B01C3}"/>
               </a:ext>
             </a:extLst>
           </p:cNvPr>
@@ -7172,7 +7172,7 @@
           <p:cNvPr id="14" name="">
             <a:extLst xmlns:a="http://schemas.openxmlformats.org/drawingml/2006/main">
               <a:ext uri="{FF2B5EF4-FFF2-40B4-BE49-F238E27FC236}">
-                <a16:creationId xmlns:a16="http://schemas.microsoft.com/office/drawing/2014/main" id="{514A8B1C-60B3-4536-9A2D-6E65F5C96305}"/>
+                <a16:creationId xmlns:a16="http://schemas.microsoft.com/office/drawing/2014/main" id="{D40D08EE-7EA3-49B4-89B9-B96730EB25C4}"/>
               </a:ext>
             </a:extLst>
           </p:cNvPr>
@@ -7238,7 +7238,7 @@
           <p:cNvPr id="15" name="">
             <a:extLst xmlns:a="http://schemas.openxmlformats.org/drawingml/2006/main">
               <a:ext uri="{FF2B5EF4-FFF2-40B4-BE49-F238E27FC236}">
-                <a16:creationId xmlns:a16="http://schemas.microsoft.com/office/drawing/2014/main" id="{123ADA81-FDC9-47F4-B2D2-5B9EB7FE7287}"/>
+                <a16:creationId xmlns:a16="http://schemas.microsoft.com/office/drawing/2014/main" id="{7CDF4006-62CC-4B6D-88C8-F09A13FD476B}"/>
               </a:ext>
             </a:extLst>
           </p:cNvPr>
@@ -7302,7 +7302,7 @@
     </p:spTree>
     <p:extLst>
       <p:ext uri="{BB962C8B-B14F-4D97-AF65-F5344CB8AC3E}">
-        <p14:creationId xmlns:p14="http://schemas.microsoft.com/office/powerpoint/2010/main" val="309662350"/>
+        <p14:creationId xmlns:p14="http://schemas.microsoft.com/office/powerpoint/2010/main" val="33157160"/>
       </p:ext>
     </p:extLst>
   </p:cSld>
@@ -7333,7 +7333,7 @@
           <p:cNvPr id="5" name="">
             <a:extLst xmlns:a="http://schemas.openxmlformats.org/drawingml/2006/main">
               <a:ext uri="{FF2B5EF4-FFF2-40B4-BE49-F238E27FC236}">
-                <a16:creationId xmlns:a16="http://schemas.microsoft.com/office/drawing/2014/main" id="{6DD00E8D-C8AE-4465-8AC5-7F447759E691}"/>
+                <a16:creationId xmlns:a16="http://schemas.microsoft.com/office/drawing/2014/main" id="{83BD096D-6C12-4705-AFC6-8B202CFCBB82}"/>
               </a:ext>
             </a:extLst>
           </p:cNvPr>
@@ -7399,7 +7399,7 @@
           <p:cNvPr id="2" name="">
             <a:extLst xmlns:a="http://schemas.openxmlformats.org/drawingml/2006/main">
               <a:ext uri="{FF2B5EF4-FFF2-40B4-BE49-F238E27FC236}">
-                <a16:creationId xmlns:a16="http://schemas.microsoft.com/office/drawing/2014/main" id="{B2301CA1-6DEA-40EA-93BC-1FA5B6CD4AC2}"/>
+                <a16:creationId xmlns:a16="http://schemas.microsoft.com/office/drawing/2014/main" id="{8C17B960-E8C1-41D8-AE43-53082DA367DA}"/>
               </a:ext>
             </a:extLst>
           </p:cNvPr>
@@ -7465,7 +7465,7 @@
           <p:cNvPr id="3" name="">
             <a:extLst xmlns:a="http://schemas.openxmlformats.org/drawingml/2006/main">
               <a:ext uri="{FF2B5EF4-FFF2-40B4-BE49-F238E27FC236}">
-                <a16:creationId xmlns:a16="http://schemas.microsoft.com/office/drawing/2014/main" id="{BD19230D-3C30-4047-A343-71B4A6E5071A}"/>
+                <a16:creationId xmlns:a16="http://schemas.microsoft.com/office/drawing/2014/main" id="{387F7D46-468C-4DA8-8637-A536C7EF1B8B}"/>
               </a:ext>
             </a:extLst>
           </p:cNvPr>
@@ -7938,7 +7938,7 @@
           <p:cNvPr id="4" name="">
             <a:extLst xmlns:a="http://schemas.openxmlformats.org/drawingml/2006/main">
               <a:ext uri="{FF2B5EF4-FFF2-40B4-BE49-F238E27FC236}">
-                <a16:creationId xmlns:a16="http://schemas.microsoft.com/office/drawing/2014/main" id="{8239B9DF-289F-4AD6-B9ED-B1A659422D22}"/>
+                <a16:creationId xmlns:a16="http://schemas.microsoft.com/office/drawing/2014/main" id="{FA47A2B5-9B96-4D34-B34D-2CBB6EF71852}"/>
               </a:ext>
             </a:extLst>
           </p:cNvPr>
@@ -8002,7 +8002,7 @@
     </p:spTree>
     <p:extLst>
       <p:ext uri="{BB962C8B-B14F-4D97-AF65-F5344CB8AC3E}">
-        <p14:creationId xmlns:p14="http://schemas.microsoft.com/office/powerpoint/2010/main" val="814169884"/>
+        <p14:creationId xmlns:p14="http://schemas.microsoft.com/office/powerpoint/2010/main" val="1279785919"/>
       </p:ext>
     </p:extLst>
   </p:cSld>
@@ -8033,7 +8033,7 @@
           <p:cNvPr id="5" name="">
             <a:extLst xmlns:a="http://schemas.openxmlformats.org/drawingml/2006/main">
               <a:ext uri="{FF2B5EF4-FFF2-40B4-BE49-F238E27FC236}">
-                <a16:creationId xmlns:a16="http://schemas.microsoft.com/office/drawing/2014/main" id="{45C9EC15-4AB9-4D1F-AC5D-BA461780A192}"/>
+                <a16:creationId xmlns:a16="http://schemas.microsoft.com/office/drawing/2014/main" id="{B987701D-FE74-4C45-B1DF-277342471BC0}"/>
               </a:ext>
             </a:extLst>
           </p:cNvPr>
@@ -8099,7 +8099,7 @@
           <p:cNvPr id="2" name="">
             <a:extLst xmlns:a="http://schemas.openxmlformats.org/drawingml/2006/main">
               <a:ext uri="{FF2B5EF4-FFF2-40B4-BE49-F238E27FC236}">
-                <a16:creationId xmlns:a16="http://schemas.microsoft.com/office/drawing/2014/main" id="{49A3D745-392E-4E3D-8DBD-47F6D53E97EC}"/>
+                <a16:creationId xmlns:a16="http://schemas.microsoft.com/office/drawing/2014/main" id="{67948E72-08C7-4F85-80AA-2F8B8B62343E}"/>
               </a:ext>
             </a:extLst>
           </p:cNvPr>
@@ -8165,7 +8165,7 @@
           <p:cNvPr id="3" name="">
             <a:extLst xmlns:a="http://schemas.openxmlformats.org/drawingml/2006/main">
               <a:ext uri="{FF2B5EF4-FFF2-40B4-BE49-F238E27FC236}">
-                <a16:creationId xmlns:a16="http://schemas.microsoft.com/office/drawing/2014/main" id="{8F4E8062-E590-4B0E-B6B2-D7AEE17499D7}"/>
+                <a16:creationId xmlns:a16="http://schemas.microsoft.com/office/drawing/2014/main" id="{F497B627-6B7C-4FDD-A25F-EDA00AF6B7CE}"/>
               </a:ext>
             </a:extLst>
           </p:cNvPr>
@@ -8181,13 +8181,13 @@
             <a:tbl>
               <a:tblPr/>
               <a:tblGrid>
-                <a:gridCol w="666750"/>
-                <a:gridCol w="1695450"/>
-                <a:gridCol w="1695450"/>
-                <a:gridCol w="1695450"/>
-                <a:gridCol w="1695450"/>
-                <a:gridCol w="1704975"/>
-                <a:gridCol w="1704975"/>
+                <a:gridCol w="952500"/>
+                <a:gridCol w="1647825"/>
+                <a:gridCol w="1647825"/>
+                <a:gridCol w="1647825"/>
+                <a:gridCol w="1647825"/>
+                <a:gridCol w="1657350"/>
+                <a:gridCol w="1657350"/>
               </a:tblGrid>
               <a:tr h="587375">
                 <a:tc>
@@ -9608,7 +9608,7 @@
           <p:cNvPr id="4" name="">
             <a:extLst xmlns:a="http://schemas.openxmlformats.org/drawingml/2006/main">
               <a:ext uri="{FF2B5EF4-FFF2-40B4-BE49-F238E27FC236}">
-                <a16:creationId xmlns:a16="http://schemas.microsoft.com/office/drawing/2014/main" id="{7205080A-4A35-4D82-97D3-BBBEC9CF7F6C}"/>
+                <a16:creationId xmlns:a16="http://schemas.microsoft.com/office/drawing/2014/main" id="{96C239D7-9B16-4A90-BB0A-88D83681737E}"/>
               </a:ext>
             </a:extLst>
           </p:cNvPr>
@@ -9672,7 +9672,7 @@
     </p:spTree>
     <p:extLst>
       <p:ext uri="{BB962C8B-B14F-4D97-AF65-F5344CB8AC3E}">
-        <p14:creationId xmlns:p14="http://schemas.microsoft.com/office/powerpoint/2010/main" val="815897636"/>
+        <p14:creationId xmlns:p14="http://schemas.microsoft.com/office/powerpoint/2010/main" val="43868062"/>
       </p:ext>
     </p:extLst>
   </p:cSld>
@@ -9703,7 +9703,7 @@
           <p:cNvPr id="5" name="">
             <a:extLst xmlns:a="http://schemas.openxmlformats.org/drawingml/2006/main">
               <a:ext uri="{FF2B5EF4-FFF2-40B4-BE49-F238E27FC236}">
-                <a16:creationId xmlns:a16="http://schemas.microsoft.com/office/drawing/2014/main" id="{FA9E10EE-3779-4E9F-A961-A05243D99A2C}"/>
+                <a16:creationId xmlns:a16="http://schemas.microsoft.com/office/drawing/2014/main" id="{A3B10062-4818-487F-9004-B8BA56328712}"/>
               </a:ext>
             </a:extLst>
           </p:cNvPr>
@@ -9769,7 +9769,7 @@
           <p:cNvPr id="2" name="">
             <a:extLst xmlns:a="http://schemas.openxmlformats.org/drawingml/2006/main">
               <a:ext uri="{FF2B5EF4-FFF2-40B4-BE49-F238E27FC236}">
-                <a16:creationId xmlns:a16="http://schemas.microsoft.com/office/drawing/2014/main" id="{5CFEC421-E91D-425D-9AA4-0417AD060CB1}"/>
+                <a16:creationId xmlns:a16="http://schemas.microsoft.com/office/drawing/2014/main" id="{E2345BC5-1305-403E-B445-73BF44109471}"/>
               </a:ext>
             </a:extLst>
           </p:cNvPr>
@@ -9835,7 +9835,7 @@
           <p:cNvPr id="3" name="">
             <a:extLst xmlns:a="http://schemas.openxmlformats.org/drawingml/2006/main">
               <a:ext uri="{FF2B5EF4-FFF2-40B4-BE49-F238E27FC236}">
-                <a16:creationId xmlns:a16="http://schemas.microsoft.com/office/drawing/2014/main" id="{CC45D2A6-9E6F-483D-8D76-D1AA05D03B56}"/>
+                <a16:creationId xmlns:a16="http://schemas.microsoft.com/office/drawing/2014/main" id="{89C571C1-7992-4464-BE0A-8C7B083E5497}"/>
               </a:ext>
             </a:extLst>
           </p:cNvPr>
@@ -10113,7 +10113,7 @@
           <p:cNvPr id="4" name="">
             <a:extLst xmlns:a="http://schemas.openxmlformats.org/drawingml/2006/main">
               <a:ext uri="{FF2B5EF4-FFF2-40B4-BE49-F238E27FC236}">
-                <a16:creationId xmlns:a16="http://schemas.microsoft.com/office/drawing/2014/main" id="{636C376F-4981-4E04-A686-94181CA040EE}"/>
+                <a16:creationId xmlns:a16="http://schemas.microsoft.com/office/drawing/2014/main" id="{E355DFE3-4240-402C-BC9B-F1AE0A4D9515}"/>
               </a:ext>
             </a:extLst>
           </p:cNvPr>
@@ -10200,7 +10200,7 @@
     </p:spTree>
     <p:extLst>
       <p:ext uri="{BB962C8B-B14F-4D97-AF65-F5344CB8AC3E}">
-        <p14:creationId xmlns:p14="http://schemas.microsoft.com/office/powerpoint/2010/main" val="1655985860"/>
+        <p14:creationId xmlns:p14="http://schemas.microsoft.com/office/powerpoint/2010/main" val="339721141"/>
       </p:ext>
     </p:extLst>
   </p:cSld>
@@ -10231,7 +10231,7 @@
           <p:cNvPr id="7" name="">
             <a:extLst xmlns:a="http://schemas.openxmlformats.org/drawingml/2006/main">
               <a:ext uri="{FF2B5EF4-FFF2-40B4-BE49-F238E27FC236}">
-                <a16:creationId xmlns:a16="http://schemas.microsoft.com/office/drawing/2014/main" id="{11612420-41E9-4B54-9DB3-8E3E806A853E}"/>
+                <a16:creationId xmlns:a16="http://schemas.microsoft.com/office/drawing/2014/main" id="{A3131C41-1175-46A7-894B-9C4B6EB032F4}"/>
               </a:ext>
             </a:extLst>
           </p:cNvPr>
@@ -10297,7 +10297,7 @@
           <p:cNvPr id="2" name="">
             <a:extLst xmlns:a="http://schemas.openxmlformats.org/drawingml/2006/main">
               <a:ext uri="{FF2B5EF4-FFF2-40B4-BE49-F238E27FC236}">
-                <a16:creationId xmlns:a16="http://schemas.microsoft.com/office/drawing/2014/main" id="{76ABDD19-ADD4-4FF1-8215-9EE8E227B0DC}"/>
+                <a16:creationId xmlns:a16="http://schemas.microsoft.com/office/drawing/2014/main" id="{1DF877D1-7E31-443A-9BC9-58ADC183ABF9}"/>
               </a:ext>
             </a:extLst>
           </p:cNvPr>
@@ -10363,7 +10363,7 @@
           <p:cNvPr id="3" name="">
             <a:extLst xmlns:a="http://schemas.openxmlformats.org/drawingml/2006/main">
               <a:ext uri="{FF2B5EF4-FFF2-40B4-BE49-F238E27FC236}">
-                <a16:creationId xmlns:a16="http://schemas.microsoft.com/office/drawing/2014/main" id="{7412E75B-DFCC-4228-BBA8-18D7CF8C2FCD}"/>
+                <a16:creationId xmlns:a16="http://schemas.microsoft.com/office/drawing/2014/main" id="{1043CDFA-3F30-43E6-B36D-3251C5BA0E99}"/>
               </a:ext>
             </a:extLst>
           </p:cNvPr>
@@ -10429,7 +10429,7 @@
           <p:cNvPr id="4" name="">
             <a:extLst xmlns:a="http://schemas.openxmlformats.org/drawingml/2006/main">
               <a:ext uri="{FF2B5EF4-FFF2-40B4-BE49-F238E27FC236}">
-                <a16:creationId xmlns:a16="http://schemas.microsoft.com/office/drawing/2014/main" id="{AE342A85-D76A-4CF7-A846-5CFDE2D820A7}"/>
+                <a16:creationId xmlns:a16="http://schemas.microsoft.com/office/drawing/2014/main" id="{E0124151-6030-4B3C-9ECE-838C390AF870}"/>
               </a:ext>
             </a:extLst>
           </p:cNvPr>
@@ -10564,7 +10564,7 @@
           <p:cNvPr id="5" name="">
             <a:extLst xmlns:a="http://schemas.openxmlformats.org/drawingml/2006/main">
               <a:ext uri="{FF2B5EF4-FFF2-40B4-BE49-F238E27FC236}">
-                <a16:creationId xmlns:a16="http://schemas.microsoft.com/office/drawing/2014/main" id="{F50D4679-08E7-4E94-9CAA-F0062EF8AAC5}"/>
+                <a16:creationId xmlns:a16="http://schemas.microsoft.com/office/drawing/2014/main" id="{3BEFBF62-3D9D-4153-B164-A587F6E85420}"/>
               </a:ext>
             </a:extLst>
           </p:cNvPr>
@@ -10722,7 +10722,7 @@
           <p:cNvPr id="6" name="">
             <a:extLst xmlns:a="http://schemas.openxmlformats.org/drawingml/2006/main">
               <a:ext uri="{FF2B5EF4-FFF2-40B4-BE49-F238E27FC236}">
-                <a16:creationId xmlns:a16="http://schemas.microsoft.com/office/drawing/2014/main" id="{81A369FB-4F14-4A5A-A621-220D876E41C9}"/>
+                <a16:creationId xmlns:a16="http://schemas.microsoft.com/office/drawing/2014/main" id="{5ADE6A3D-865B-408C-979D-595F042C3BB8}"/>
               </a:ext>
             </a:extLst>
           </p:cNvPr>
@@ -10809,7 +10809,7 @@
     </p:spTree>
     <p:extLst>
       <p:ext uri="{BB962C8B-B14F-4D97-AF65-F5344CB8AC3E}">
-        <p14:creationId xmlns:p14="http://schemas.microsoft.com/office/powerpoint/2010/main" val="751001853"/>
+        <p14:creationId xmlns:p14="http://schemas.microsoft.com/office/powerpoint/2010/main" val="1928678855"/>
       </p:ext>
     </p:extLst>
   </p:cSld>

</xml_diff>